<commit_message>
Clarify grill-me example for internal API access
</commit_message>
<xml_diff>
--- a/decks/grill-me/artifacts/agent-skills-lt.pptx
+++ b/decks/grill-me/artifacts/agent-skills-lt.pptx
@@ -2,23 +2,23 @@
 <file path=ppt/presentation.xml><?xml version="1.0" encoding="utf-8"?>
 <p:presentation xmlns:p="http://schemas.openxmlformats.org/presentationml/2006/main">
   <p:sldMasterIdLst>
-    <p:sldMasterId xmlns:r="http://schemas.openxmlformats.org/officeDocument/2006/relationships" id="2147483648" r:id="R1df3a837c2fd4344"/>
+    <p:sldMasterId xmlns:r="http://schemas.openxmlformats.org/officeDocument/2006/relationships" id="2147483648" r:id="Rd726efbd4e664c2c"/>
   </p:sldMasterIdLst>
   <p:notesMasterIdLst>
-    <p:notesMasterId xmlns:r="http://schemas.openxmlformats.org/officeDocument/2006/relationships" r:id="Rfe0b39573aeb49b7"/>
+    <p:notesMasterId xmlns:r="http://schemas.openxmlformats.org/officeDocument/2006/relationships" r:id="Rd90765acdd2a41bc"/>
   </p:notesMasterIdLst>
   <p:sldIdLst>
-    <p:sldId xmlns:r="http://schemas.openxmlformats.org/officeDocument/2006/relationships" id="256" r:id="R1651191f91c342a9"/>
-    <p:sldId xmlns:r="http://schemas.openxmlformats.org/officeDocument/2006/relationships" id="257" r:id="R43574ba662414fdf"/>
-    <p:sldId xmlns:r="http://schemas.openxmlformats.org/officeDocument/2006/relationships" id="258" r:id="R3947898a9e5a4a36"/>
-    <p:sldId xmlns:r="http://schemas.openxmlformats.org/officeDocument/2006/relationships" id="259" r:id="R4342f077e19e4acb"/>
-    <p:sldId xmlns:r="http://schemas.openxmlformats.org/officeDocument/2006/relationships" id="260" r:id="R0bac033964bb4d6d"/>
-    <p:sldId xmlns:r="http://schemas.openxmlformats.org/officeDocument/2006/relationships" id="261" r:id="Rdfbc177d6f0c470b"/>
-    <p:sldId xmlns:r="http://schemas.openxmlformats.org/officeDocument/2006/relationships" id="262" r:id="Rf6c4513bf6e14c4a"/>
-    <p:sldId xmlns:r="http://schemas.openxmlformats.org/officeDocument/2006/relationships" id="263" r:id="R7da91903d463404a"/>
-    <p:sldId xmlns:r="http://schemas.openxmlformats.org/officeDocument/2006/relationships" id="264" r:id="R45651f9e1e404458"/>
-    <p:sldId xmlns:r="http://schemas.openxmlformats.org/officeDocument/2006/relationships" id="265" r:id="Re1d8c005215f47ab"/>
-    <p:sldId xmlns:r="http://schemas.openxmlformats.org/officeDocument/2006/relationships" id="266" r:id="Rdfdc72aea2b349a6"/>
+    <p:sldId xmlns:r="http://schemas.openxmlformats.org/officeDocument/2006/relationships" id="256" r:id="Ra403420fd2e54583"/>
+    <p:sldId xmlns:r="http://schemas.openxmlformats.org/officeDocument/2006/relationships" id="257" r:id="R94f908d59a9945e3"/>
+    <p:sldId xmlns:r="http://schemas.openxmlformats.org/officeDocument/2006/relationships" id="258" r:id="Rb3528d877b9a4030"/>
+    <p:sldId xmlns:r="http://schemas.openxmlformats.org/officeDocument/2006/relationships" id="259" r:id="R7dea5c832af74fdc"/>
+    <p:sldId xmlns:r="http://schemas.openxmlformats.org/officeDocument/2006/relationships" id="260" r:id="R4eaee1f295e74d2b"/>
+    <p:sldId xmlns:r="http://schemas.openxmlformats.org/officeDocument/2006/relationships" id="261" r:id="R1e6973a11afd49ae"/>
+    <p:sldId xmlns:r="http://schemas.openxmlformats.org/officeDocument/2006/relationships" id="262" r:id="R4659693107864509"/>
+    <p:sldId xmlns:r="http://schemas.openxmlformats.org/officeDocument/2006/relationships" id="263" r:id="R8cb82f8ba43042d5"/>
+    <p:sldId xmlns:r="http://schemas.openxmlformats.org/officeDocument/2006/relationships" id="264" r:id="R4dd76231054c4891"/>
+    <p:sldId xmlns:r="http://schemas.openxmlformats.org/officeDocument/2006/relationships" id="265" r:id="R5fe155da00c74670"/>
+    <p:sldId xmlns:r="http://schemas.openxmlformats.org/officeDocument/2006/relationships" id="266" r:id="R0ee3e57b9e0142cd"/>
   </p:sldIdLst>
   <p:sldSz cx="12192000" cy="6858000"/>
   <p:notesSz cx="6858000" cy="9144000"/>
@@ -1450,7 +1450,7 @@
   </p:cSld>
   <p:clrMap bg1="lt1" tx1="dk1" bg2="lt2" tx2="dk2" accent1="accent1" accent2="accent2" accent3="accent3" accent4="accent4" accent5="accent5" accent6="accent6" hlink="hlink" folHlink="folHlink"/>
   <p:sldLayoutIdLst>
-    <p:sldLayoutId xmlns:r="http://schemas.openxmlformats.org/officeDocument/2006/relationships" id="2147483649" r:id="R250eac950ee34a70"/>
+    <p:sldLayoutId xmlns:r="http://schemas.openxmlformats.org/officeDocument/2006/relationships" id="2147483649" r:id="R527ce637e5034e96"/>
   </p:sldLayoutIdLst>
   <p:txStyles>
     <p:titleStyle>
@@ -2001,7 +2001,7 @@
           <p:cNvPr id="6" name="01">
             <a:extLst xmlns:a="http://schemas.openxmlformats.org/drawingml/2006/main">
               <a:ext uri="{FF2B5EF4-FFF2-40B4-BE49-F238E27FC236}">
-                <a16:creationId xmlns:a16="http://schemas.microsoft.com/office/drawing/2014/main" id="{AB755785-DBA3-4800-8123-AD64CC3BBCD7}"/>
+                <a16:creationId xmlns:a16="http://schemas.microsoft.com/office/drawing/2014/main" id="{726E0B61-EACC-43EC-BE78-3FF61731F951}"/>
               </a:ext>
             </a:extLst>
           </p:cNvPr>
@@ -2058,7 +2058,7 @@
           <p:cNvPr id="2" name="社内LT">
             <a:extLst xmlns:a="http://schemas.openxmlformats.org/drawingml/2006/main">
               <a:ext uri="{FF2B5EF4-FFF2-40B4-BE49-F238E27FC236}">
-                <a16:creationId xmlns:a16="http://schemas.microsoft.com/office/drawing/2014/main" id="{9624D021-B70D-4CE1-97D4-643530EFAF10}"/>
+                <a16:creationId xmlns:a16="http://schemas.microsoft.com/office/drawing/2014/main" id="{457A5620-6FA7-4BAE-A349-D344D84B0AF0}"/>
               </a:ext>
             </a:extLst>
           </p:cNvPr>
@@ -2115,7 +2115,7 @@
           <p:cNvPr id="3" name="公開されている">
             <a:extLst xmlns:a="http://schemas.openxmlformats.org/drawingml/2006/main">
               <a:ext uri="{FF2B5EF4-FFF2-40B4-BE49-F238E27FC236}">
-                <a16:creationId xmlns:a16="http://schemas.microsoft.com/office/drawing/2014/main" id="{A4E9D684-92C5-4383-A31C-5F9BCB26F56F}"/>
+                <a16:creationId xmlns:a16="http://schemas.microsoft.com/office/drawing/2014/main" id="{07C3B611-0A87-4E02-8A19-7C39015BAF7B}"/>
               </a:ext>
             </a:extLst>
           </p:cNvPr>
@@ -2172,7 +2172,7 @@
           <p:cNvPr id="4" name="Agent Skillsを使ってみる">
             <a:extLst xmlns:a="http://schemas.openxmlformats.org/drawingml/2006/main">
               <a:ext uri="{FF2B5EF4-FFF2-40B4-BE49-F238E27FC236}">
-                <a16:creationId xmlns:a16="http://schemas.microsoft.com/office/drawing/2014/main" id="{2C0E86CD-C692-4E47-9965-BDB634FC5D0F}"/>
+                <a16:creationId xmlns:a16="http://schemas.microsoft.com/office/drawing/2014/main" id="{1B5BA8CD-2FDB-4619-994E-9B42009AC528}"/>
               </a:ext>
             </a:extLst>
           </p:cNvPr>
@@ -2229,7 +2229,7 @@
           <p:cNvPr id="5" name="grill-meの紹介">
             <a:extLst xmlns:a="http://schemas.openxmlformats.org/drawingml/2006/main">
               <a:ext uri="{FF2B5EF4-FFF2-40B4-BE49-F238E27FC236}">
-                <a16:creationId xmlns:a16="http://schemas.microsoft.com/office/drawing/2014/main" id="{3AA5E5CA-2C9F-47C1-A9F6-DC2EDC1BEC6D}"/>
+                <a16:creationId xmlns:a16="http://schemas.microsoft.com/office/drawing/2014/main" id="{5372C925-77CC-4CF3-80BB-D21E80DD3944}"/>
               </a:ext>
             </a:extLst>
           </p:cNvPr>
@@ -2284,7 +2284,7 @@
     </p:spTree>
     <p:extLst>
       <p:ext uri="{BB962C8B-B14F-4D97-AF65-F5344CB8AC3E}">
-        <p14:creationId xmlns:p14="http://schemas.microsoft.com/office/powerpoint/2010/main" val="287698533"/>
+        <p14:creationId xmlns:p14="http://schemas.microsoft.com/office/powerpoint/2010/main" val="792413010"/>
       </p:ext>
     </p:extLst>
   </p:cSld>
@@ -2315,7 +2315,7 @@
           <p:cNvPr id="8" name="質問が広がりすぎたとき">
             <a:extLst xmlns:a="http://schemas.openxmlformats.org/drawingml/2006/main">
               <a:ext uri="{FF2B5EF4-FFF2-40B4-BE49-F238E27FC236}">
-                <a16:creationId xmlns:a16="http://schemas.microsoft.com/office/drawing/2014/main" id="{7ABE1639-BF63-42E1-97C0-5B70F2D6CFBB}"/>
+                <a16:creationId xmlns:a16="http://schemas.microsoft.com/office/drawing/2014/main" id="{3D7EA7FD-BD73-4FFF-9879-302B9E22F8E8}"/>
               </a:ext>
             </a:extLst>
           </p:cNvPr>
@@ -2372,7 +2372,7 @@
           <p:cNvPr id="2" name="10">
             <a:extLst xmlns:a="http://schemas.openxmlformats.org/drawingml/2006/main">
               <a:ext uri="{FF2B5EF4-FFF2-40B4-BE49-F238E27FC236}">
-                <a16:creationId xmlns:a16="http://schemas.microsoft.com/office/drawing/2014/main" id="{ACC92F55-8568-4B73-9158-0E8E011ADB8C}"/>
+                <a16:creationId xmlns:a16="http://schemas.microsoft.com/office/drawing/2014/main" id="{88E6FD79-9085-4EA8-8862-5093FD8E2B60}"/>
               </a:ext>
             </a:extLst>
           </p:cNvPr>
@@ -2429,7 +2429,7 @@
           <p:cNvPr id="3" name="「今回は認証と公開範囲だけ決めたいです」">
             <a:extLst xmlns:a="http://schemas.openxmlformats.org/drawingml/2006/main">
               <a:ext uri="{FF2B5EF4-FFF2-40B4-BE49-F238E27FC236}">
-                <a16:creationId xmlns:a16="http://schemas.microsoft.com/office/drawing/2014/main" id="{514635A6-510C-478D-BC2C-1C107DA7AE29}"/>
+                <a16:creationId xmlns:a16="http://schemas.microsoft.com/office/drawing/2014/main" id="{166E9768-5FD3-4E77-AFDD-395E541AB08D}"/>
               </a:ext>
             </a:extLst>
           </p:cNvPr>
@@ -2486,7 +2486,7 @@
           <p:cNvPr id="4" name="何を決めたいか、範囲を指定する。">
             <a:extLst xmlns:a="http://schemas.openxmlformats.org/drawingml/2006/main">
               <a:ext uri="{FF2B5EF4-FFF2-40B4-BE49-F238E27FC236}">
-                <a16:creationId xmlns:a16="http://schemas.microsoft.com/office/drawing/2014/main" id="{CCBCC610-9D0C-48B8-8E26-67A729084099}"/>
+                <a16:creationId xmlns:a16="http://schemas.microsoft.com/office/drawing/2014/main" id="{431B3237-EDE5-447F-BB16-C516540EBCF7}"/>
               </a:ext>
             </a:extLst>
           </p:cNvPr>
@@ -2543,7 +2543,7 @@
           <p:cNvPr id="5" name="「性能はまだ分かりません。&#10;　検証項目にしてください」">
             <a:extLst xmlns:a="http://schemas.openxmlformats.org/drawingml/2006/main">
               <a:ext uri="{FF2B5EF4-FFF2-40B4-BE49-F238E27FC236}">
-                <a16:creationId xmlns:a16="http://schemas.microsoft.com/office/drawing/2014/main" id="{99FF1B43-098D-406D-AD57-1BD41E3685DA}"/>
+                <a16:creationId xmlns:a16="http://schemas.microsoft.com/office/drawing/2014/main" id="{D288E682-9380-4944-B896-3B87DA4C4428}"/>
               </a:ext>
             </a:extLst>
           </p:cNvPr>
@@ -2631,7 +2631,7 @@
           <p:cNvPr id="6" name="分からないことまで、その場で決めなくてよい。">
             <a:extLst xmlns:a="http://schemas.openxmlformats.org/drawingml/2006/main">
               <a:ext uri="{FF2B5EF4-FFF2-40B4-BE49-F238E27FC236}">
-                <a16:creationId xmlns:a16="http://schemas.microsoft.com/office/drawing/2014/main" id="{B34F07FE-2C5B-416A-B25E-5F3F00C72062}"/>
+                <a16:creationId xmlns:a16="http://schemas.microsoft.com/office/drawing/2014/main" id="{0E676421-A9B6-4FE5-9FEC-F4006B6F59A9}"/>
               </a:ext>
             </a:extLst>
           </p:cNvPr>
@@ -2688,7 +2688,7 @@
           <p:cNvPr id="7" name="推奨案も確認は必要。製品仕様の調査や性能の実測は、別に行います。">
             <a:extLst xmlns:a="http://schemas.openxmlformats.org/drawingml/2006/main">
               <a:ext uri="{FF2B5EF4-FFF2-40B4-BE49-F238E27FC236}">
-                <a16:creationId xmlns:a16="http://schemas.microsoft.com/office/drawing/2014/main" id="{8E9E3FBE-BE4F-4B98-B7FC-4CE34B421897}"/>
+                <a16:creationId xmlns:a16="http://schemas.microsoft.com/office/drawing/2014/main" id="{3A1660F8-CF2C-4CC1-B31C-CA4C16E0331F}"/>
               </a:ext>
             </a:extLst>
           </p:cNvPr>
@@ -2743,7 +2743,7 @@
     </p:spTree>
     <p:extLst>
       <p:ext uri="{BB962C8B-B14F-4D97-AF65-F5344CB8AC3E}">
-        <p14:creationId xmlns:p14="http://schemas.microsoft.com/office/powerpoint/2010/main" val="1291846684"/>
+        <p14:creationId xmlns:p14="http://schemas.microsoft.com/office/powerpoint/2010/main" val="1903275098"/>
       </p:ext>
     </p:extLst>
   </p:cSld>
@@ -2774,7 +2774,7 @@
           <p:cNvPr id="10" name="参考資料">
             <a:extLst xmlns:a="http://schemas.openxmlformats.org/drawingml/2006/main">
               <a:ext uri="{FF2B5EF4-FFF2-40B4-BE49-F238E27FC236}">
-                <a16:creationId xmlns:a16="http://schemas.microsoft.com/office/drawing/2014/main" id="{6ED4A0B6-416A-4995-8FF7-A6E847E3289A}"/>
+                <a16:creationId xmlns:a16="http://schemas.microsoft.com/office/drawing/2014/main" id="{6647A36D-3452-4F87-8E29-CBC07CF9D2F8}"/>
               </a:ext>
             </a:extLst>
           </p:cNvPr>
@@ -2831,7 +2831,7 @@
           <p:cNvPr id="2" name="11">
             <a:extLst xmlns:a="http://schemas.openxmlformats.org/drawingml/2006/main">
               <a:ext uri="{FF2B5EF4-FFF2-40B4-BE49-F238E27FC236}">
-                <a16:creationId xmlns:a16="http://schemas.microsoft.com/office/drawing/2014/main" id="{55505274-5883-4A26-BDEA-B72B944268BF}"/>
+                <a16:creationId xmlns:a16="http://schemas.microsoft.com/office/drawing/2014/main" id="{1C6D26DE-7B63-418F-9AC3-AE2BE2F81E66}"/>
               </a:ext>
             </a:extLst>
           </p:cNvPr>
@@ -2888,7 +2888,7 @@
           <p:cNvPr id="3" name="公開Skillsの一覧と追加方法">
             <a:extLst xmlns:a="http://schemas.openxmlformats.org/drawingml/2006/main">
               <a:ext uri="{FF2B5EF4-FFF2-40B4-BE49-F238E27FC236}">
-                <a16:creationId xmlns:a16="http://schemas.microsoft.com/office/drawing/2014/main" id="{DF5EC009-E2F9-461C-B064-C9D0C598315A}"/>
+                <a16:creationId xmlns:a16="http://schemas.microsoft.com/office/drawing/2014/main" id="{E9C3ECAD-FA1F-4C00-8975-EDA67E90E218}"/>
               </a:ext>
             </a:extLst>
           </p:cNvPr>
@@ -2945,7 +2945,7 @@
           <p:cNvPr id="4" name="github.com/mattpocock/skills">
             <a:extLst xmlns:a="http://schemas.openxmlformats.org/drawingml/2006/main">
               <a:ext uri="{FF2B5EF4-FFF2-40B4-BE49-F238E27FC236}">
-                <a16:creationId xmlns:a16="http://schemas.microsoft.com/office/drawing/2014/main" id="{439FF1DE-E475-4051-A46C-F9926CAF9528}"/>
+                <a16:creationId xmlns:a16="http://schemas.microsoft.com/office/drawing/2014/main" id="{2E5DAE95-2D15-442A-AA38-F441EF8F19A4}"/>
               </a:ext>
             </a:extLst>
           </p:cNvPr>
@@ -2991,7 +2991,7 @@
                 <a:latin typeface="Noto Sans JP"/>
                 <a:ea typeface="Noto Sans JP"/>
                 <a:cs typeface="Noto Sans JP"/>
-                <a:hlinkClick xmlns:r="http://schemas.openxmlformats.org/officeDocument/2006/relationships" r:id="R420e37c18fb547ca"/>
+                <a:hlinkClick xmlns:r="http://schemas.openxmlformats.org/officeDocument/2006/relationships" r:id="R01790fd762514520"/>
               </a:rPr>
               <a:t>github.com/mattpocock/skills</a:t>
             </a:r>
@@ -3003,7 +3003,7 @@
           <p:cNvPr id="5" name="質問に答えて、案や要件を詰める">
             <a:extLst xmlns:a="http://schemas.openxmlformats.org/drawingml/2006/main">
               <a:ext uri="{FF2B5EF4-FFF2-40B4-BE49-F238E27FC236}">
-                <a16:creationId xmlns:a16="http://schemas.microsoft.com/office/drawing/2014/main" id="{5B01C12F-A4BD-44A3-8B8B-A3B6A879C43C}"/>
+                <a16:creationId xmlns:a16="http://schemas.microsoft.com/office/drawing/2014/main" id="{9E886F64-4C43-4059-B677-D768F3F54CD7}"/>
               </a:ext>
             </a:extLst>
           </p:cNvPr>
@@ -3060,7 +3060,7 @@
           <p:cNvPr id="6" name="grill-me / SKILL.md">
             <a:extLst xmlns:a="http://schemas.openxmlformats.org/drawingml/2006/main">
               <a:ext uri="{FF2B5EF4-FFF2-40B4-BE49-F238E27FC236}">
-                <a16:creationId xmlns:a16="http://schemas.microsoft.com/office/drawing/2014/main" id="{CDD3A7E5-ADF1-4DFB-B769-D0AEBCE81F49}"/>
+                <a16:creationId xmlns:a16="http://schemas.microsoft.com/office/drawing/2014/main" id="{7F764C19-9CD0-4177-89D0-55ECFDA8F6B3}"/>
               </a:ext>
             </a:extLst>
           </p:cNvPr>
@@ -3106,7 +3106,7 @@
                 <a:latin typeface="Noto Sans JP"/>
                 <a:ea typeface="Noto Sans JP"/>
                 <a:cs typeface="Noto Sans JP"/>
-                <a:hlinkClick xmlns:r="http://schemas.openxmlformats.org/officeDocument/2006/relationships" r:id="R36ee9e7b838c4bba"/>
+                <a:hlinkClick xmlns:r="http://schemas.openxmlformats.org/officeDocument/2006/relationships" r:id="R0008c01098ae4201"/>
               </a:rPr>
               <a:t>grill-me / SKILL.md</a:t>
             </a:r>
@@ -3118,7 +3118,7 @@
           <p:cNvPr id="7" name="用語や設計判断も文書に残す">
             <a:extLst xmlns:a="http://schemas.openxmlformats.org/drawingml/2006/main">
               <a:ext uri="{FF2B5EF4-FFF2-40B4-BE49-F238E27FC236}">
-                <a16:creationId xmlns:a16="http://schemas.microsoft.com/office/drawing/2014/main" id="{388C16F6-5361-4D86-AD64-28904A3060FD}"/>
+                <a16:creationId xmlns:a16="http://schemas.microsoft.com/office/drawing/2014/main" id="{27A414CA-9A5B-4CA5-9A62-52B838C37B0B}"/>
               </a:ext>
             </a:extLst>
           </p:cNvPr>
@@ -3175,7 +3175,7 @@
           <p:cNvPr id="8" name="grill-with-docs / SKILL.md">
             <a:extLst xmlns:a="http://schemas.openxmlformats.org/drawingml/2006/main">
               <a:ext uri="{FF2B5EF4-FFF2-40B4-BE49-F238E27FC236}">
-                <a16:creationId xmlns:a16="http://schemas.microsoft.com/office/drawing/2014/main" id="{5FA6C512-1DCC-4D9D-817F-AFF358CC9C70}"/>
+                <a16:creationId xmlns:a16="http://schemas.microsoft.com/office/drawing/2014/main" id="{CE583165-3CEC-49F0-9CE7-9CC4FF92D025}"/>
               </a:ext>
             </a:extLst>
           </p:cNvPr>
@@ -3221,7 +3221,7 @@
                 <a:latin typeface="Noto Sans JP"/>
                 <a:ea typeface="Noto Sans JP"/>
                 <a:cs typeface="Noto Sans JP"/>
-                <a:hlinkClick xmlns:r="http://schemas.openxmlformats.org/officeDocument/2006/relationships" r:id="Rc0a7998686f345a0"/>
+                <a:hlinkClick xmlns:r="http://schemas.openxmlformats.org/officeDocument/2006/relationships" r:id="Rb6b273c3ad654768"/>
               </a:rPr>
               <a:t>grill-with-docs / SKILL.md</a:t>
             </a:r>
@@ -3233,7 +3233,7 @@
           <p:cNvPr id="9" name="公開元：Matt Pocock / mattpocock/skills（MIT）">
             <a:extLst xmlns:a="http://schemas.openxmlformats.org/drawingml/2006/main">
               <a:ext uri="{FF2B5EF4-FFF2-40B4-BE49-F238E27FC236}">
-                <a16:creationId xmlns:a16="http://schemas.microsoft.com/office/drawing/2014/main" id="{25E217BE-863E-4942-BA5C-3C58FF674484}"/>
+                <a16:creationId xmlns:a16="http://schemas.microsoft.com/office/drawing/2014/main" id="{79C97A37-E816-4AA8-89E5-065722FD5B3E}"/>
               </a:ext>
             </a:extLst>
           </p:cNvPr>
@@ -3288,7 +3288,7 @@
     </p:spTree>
     <p:extLst>
       <p:ext uri="{BB962C8B-B14F-4D97-AF65-F5344CB8AC3E}">
-        <p14:creationId xmlns:p14="http://schemas.microsoft.com/office/powerpoint/2010/main" val="1034126760"/>
+        <p14:creationId xmlns:p14="http://schemas.microsoft.com/office/powerpoint/2010/main" val="1195269903"/>
       </p:ext>
     </p:extLst>
   </p:cSld>
@@ -3319,7 +3319,7 @@
           <p:cNvPr id="8" name="Skills、自分で作り込んでいませんか？">
             <a:extLst xmlns:a="http://schemas.openxmlformats.org/drawingml/2006/main">
               <a:ext uri="{FF2B5EF4-FFF2-40B4-BE49-F238E27FC236}">
-                <a16:creationId xmlns:a16="http://schemas.microsoft.com/office/drawing/2014/main" id="{AF622652-1BA4-4269-8153-DF11F0EEC322}"/>
+                <a16:creationId xmlns:a16="http://schemas.microsoft.com/office/drawing/2014/main" id="{49CA2628-BDF8-4239-83F3-CE6C98CE009E}"/>
               </a:ext>
             </a:extLst>
           </p:cNvPr>
@@ -3376,7 +3376,7 @@
           <p:cNvPr id="2" name="02">
             <a:extLst xmlns:a="http://schemas.openxmlformats.org/drawingml/2006/main">
               <a:ext uri="{FF2B5EF4-FFF2-40B4-BE49-F238E27FC236}">
-                <a16:creationId xmlns:a16="http://schemas.microsoft.com/office/drawing/2014/main" id="{AF48E924-F7AE-406D-A217-A74D613D8944}"/>
+                <a16:creationId xmlns:a16="http://schemas.microsoft.com/office/drawing/2014/main" id="{75EA8EAF-EEE2-4EA2-888C-537C0A5854CD}"/>
               </a:ext>
             </a:extLst>
           </p:cNvPr>
@@ -3433,7 +3433,7 @@
           <p:cNvPr id="3" name="モデルが変わったら、指示も見直す">
             <a:extLst xmlns:a="http://schemas.openxmlformats.org/drawingml/2006/main">
               <a:ext uri="{FF2B5EF4-FFF2-40B4-BE49-F238E27FC236}">
-                <a16:creationId xmlns:a16="http://schemas.microsoft.com/office/drawing/2014/main" id="{0EC445E5-2037-475A-BD8B-81B8ABB77FEB}"/>
+                <a16:creationId xmlns:a16="http://schemas.microsoft.com/office/drawing/2014/main" id="{97C6C1C6-0F54-4399-A80C-75E0F296C047}"/>
               </a:ext>
             </a:extLst>
           </p:cNvPr>
@@ -3490,7 +3490,7 @@
           <p:cNvPr id="4" name="以前のモデル向けに足した手順が、&#10;更新後も必要とは限らない。">
             <a:extLst xmlns:a="http://schemas.openxmlformats.org/drawingml/2006/main">
               <a:ext uri="{FF2B5EF4-FFF2-40B4-BE49-F238E27FC236}">
-                <a16:creationId xmlns:a16="http://schemas.microsoft.com/office/drawing/2014/main" id="{2BE836B2-B9B1-4E0A-8C2E-8B49410FFD79}"/>
+                <a16:creationId xmlns:a16="http://schemas.microsoft.com/office/drawing/2014/main" id="{BB04FCCD-5C07-453B-BE81-D7BA9EF4E750}"/>
               </a:ext>
             </a:extLst>
           </p:cNvPr>
@@ -3578,7 +3578,7 @@
           <p:cNvPr id="5" name="作ったあとも、動作確認と修正が続く">
             <a:extLst xmlns:a="http://schemas.openxmlformats.org/drawingml/2006/main">
               <a:ext uri="{FF2B5EF4-FFF2-40B4-BE49-F238E27FC236}">
-                <a16:creationId xmlns:a16="http://schemas.microsoft.com/office/drawing/2014/main" id="{28FED297-2493-4710-BCD8-01DCB1929039}"/>
+                <a16:creationId xmlns:a16="http://schemas.microsoft.com/office/drawing/2014/main" id="{D47B4523-EF2A-4DC6-A7C5-7A0F08E3538A}"/>
               </a:ext>
             </a:extLst>
           </p:cNvPr>
@@ -3635,7 +3635,7 @@
           <p:cNvPr id="6" name="指示を足すたびに、別のタスクでも使えるか確かめる。">
             <a:extLst xmlns:a="http://schemas.openxmlformats.org/drawingml/2006/main">
               <a:ext uri="{FF2B5EF4-FFF2-40B4-BE49-F238E27FC236}">
-                <a16:creationId xmlns:a16="http://schemas.microsoft.com/office/drawing/2014/main" id="{2CFBFA0F-29EB-4145-B459-17CD98A02662}"/>
+                <a16:creationId xmlns:a16="http://schemas.microsoft.com/office/drawing/2014/main" id="{4F38C8E8-D374-4AE7-8275-13CD37CF70AC}"/>
               </a:ext>
             </a:extLst>
           </p:cNvPr>
@@ -3692,7 +3692,7 @@
           <p:cNvPr id="7" name="自作する前に、公開Skillsも探してみる。">
             <a:extLst xmlns:a="http://schemas.openxmlformats.org/drawingml/2006/main">
               <a:ext uri="{FF2B5EF4-FFF2-40B4-BE49-F238E27FC236}">
-                <a16:creationId xmlns:a16="http://schemas.microsoft.com/office/drawing/2014/main" id="{BF671599-E66D-46E4-ACF2-67478F2F5C04}"/>
+                <a16:creationId xmlns:a16="http://schemas.microsoft.com/office/drawing/2014/main" id="{C18E1385-95E8-4A27-B15C-7F1B8DF9F65B}"/>
               </a:ext>
             </a:extLst>
           </p:cNvPr>
@@ -3747,7 +3747,7 @@
     </p:spTree>
     <p:extLst>
       <p:ext uri="{BB962C8B-B14F-4D97-AF65-F5344CB8AC3E}">
-        <p14:creationId xmlns:p14="http://schemas.microsoft.com/office/powerpoint/2010/main" val="128451175"/>
+        <p14:creationId xmlns:p14="http://schemas.microsoft.com/office/powerpoint/2010/main" val="1991425264"/>
       </p:ext>
     </p:extLst>
   </p:cSld>
@@ -3778,7 +3778,7 @@
           <p:cNvPr id="8" name="公開されているSkillsも使える">
             <a:extLst xmlns:a="http://schemas.openxmlformats.org/drawingml/2006/main">
               <a:ext uri="{FF2B5EF4-FFF2-40B4-BE49-F238E27FC236}">
-                <a16:creationId xmlns:a16="http://schemas.microsoft.com/office/drawing/2014/main" id="{0BFA2B92-CFF7-41FA-A57A-FEC088079BA8}"/>
+                <a16:creationId xmlns:a16="http://schemas.microsoft.com/office/drawing/2014/main" id="{D0B8C1A8-FEE0-4875-91C8-340345B0A7D2}"/>
               </a:ext>
             </a:extLst>
           </p:cNvPr>
@@ -3835,7 +3835,7 @@
           <p:cNvPr id="2" name="03">
             <a:extLst xmlns:a="http://schemas.openxmlformats.org/drawingml/2006/main">
               <a:ext uri="{FF2B5EF4-FFF2-40B4-BE49-F238E27FC236}">
-                <a16:creationId xmlns:a16="http://schemas.microsoft.com/office/drawing/2014/main" id="{B4AA3418-6E4E-47EE-AE9A-95D3A3B2A386}"/>
+                <a16:creationId xmlns:a16="http://schemas.microsoft.com/office/drawing/2014/main" id="{5B25439D-53B6-4CC7-84BC-C0E939DF64F3}"/>
               </a:ext>
             </a:extLst>
           </p:cNvPr>
@@ -3892,7 +3892,7 @@
           <p:cNvPr id="3" name="GitHubなどで公開されているSkillを&#10;Claude Codeなどに追加し">
             <a:extLst xmlns:a="http://schemas.openxmlformats.org/drawingml/2006/main">
               <a:ext uri="{FF2B5EF4-FFF2-40B4-BE49-F238E27FC236}">
-                <a16:creationId xmlns:a16="http://schemas.microsoft.com/office/drawing/2014/main" id="{6B3BF3CF-4207-450C-B214-159FB78FC950}"/>
+                <a16:creationId xmlns:a16="http://schemas.microsoft.com/office/drawing/2014/main" id="{F5C94AA1-8DF6-45A7-861A-98FA6E80FA3F}"/>
               </a:ext>
             </a:extLst>
           </p:cNvPr>
@@ -3980,7 +3980,7 @@
           <p:cNvPr id="4" name="手順を一から書かずに、&#10;公開されているものを試せる。">
             <a:extLst xmlns:a="http://schemas.openxmlformats.org/drawingml/2006/main">
               <a:ext uri="{FF2B5EF4-FFF2-40B4-BE49-F238E27FC236}">
-                <a16:creationId xmlns:a16="http://schemas.microsoft.com/office/drawing/2014/main" id="{AC96E517-684F-4A0F-912E-D64EE88E654A}"/>
+                <a16:creationId xmlns:a16="http://schemas.microsoft.com/office/drawing/2014/main" id="{EBEE663A-6807-4C73-8178-FE1F18CD3EEF}"/>
               </a:ext>
             </a:extLst>
           </p:cNvPr>
@@ -4072,7 +4072,7 @@
           <p:nvPr/>
         </p:nvPicPr>
         <p:blipFill>
-          <a:blip xmlns:r="http://schemas.openxmlformats.org/officeDocument/2006/relationships" xmlns:a="http://schemas.openxmlformats.org/drawingml/2006/main" r:embed="Rc56ce0a9db434d87"/>
+          <a:blip xmlns:r="http://schemas.openxmlformats.org/officeDocument/2006/relationships" xmlns:a="http://schemas.openxmlformats.org/drawingml/2006/main" r:embed="R58b004f50f8641ae"/>
           <a:stretch xmlns:a="http://schemas.openxmlformats.org/drawingml/2006/main"/>
         </p:blipFill>
         <p:spPr>
@@ -4090,7 +4090,7 @@
           <p:cNvPr id="6" name="追加前に内容を確認し、手元のタスクで試す。">
             <a:extLst xmlns:a="http://schemas.openxmlformats.org/drawingml/2006/main">
               <a:ext uri="{FF2B5EF4-FFF2-40B4-BE49-F238E27FC236}">
-                <a16:creationId xmlns:a16="http://schemas.microsoft.com/office/drawing/2014/main" id="{48F9AD0B-EDFB-4294-ABB3-C88911D86026}"/>
+                <a16:creationId xmlns:a16="http://schemas.microsoft.com/office/drawing/2014/main" id="{3114BE7D-2410-4C9C-A327-B4E319055723}"/>
               </a:ext>
             </a:extLst>
           </p:cNvPr>
@@ -4147,7 +4147,7 @@
           <p:cNvPr id="7" name="公開例：Matt Pocock / mattpocock/skills（MITラ">
             <a:extLst xmlns:a="http://schemas.openxmlformats.org/drawingml/2006/main">
               <a:ext uri="{FF2B5EF4-FFF2-40B4-BE49-F238E27FC236}">
-                <a16:creationId xmlns:a16="http://schemas.microsoft.com/office/drawing/2014/main" id="{A1B85F7B-9948-415C-A974-F5D5B4386155}"/>
+                <a16:creationId xmlns:a16="http://schemas.microsoft.com/office/drawing/2014/main" id="{78FEDD9B-2105-42B1-A12B-2460930A41DB}"/>
               </a:ext>
             </a:extLst>
           </p:cNvPr>
@@ -4193,7 +4193,7 @@
                 <a:latin typeface="Noto Sans JP"/>
                 <a:ea typeface="Noto Sans JP"/>
                 <a:cs typeface="Noto Sans JP"/>
-                <a:hlinkClick xmlns:r="http://schemas.openxmlformats.org/officeDocument/2006/relationships" r:id="Ree8bdaf0524c4c68"/>
+                <a:hlinkClick xmlns:r="http://schemas.openxmlformats.org/officeDocument/2006/relationships" r:id="Rbcd66dfe465943fc"/>
               </a:rPr>
               <a:t>公開例：Matt Pocock / mattpocock/skills（MITライセンス）</a:t>
             </a:r>
@@ -4203,7 +4203,7 @@
     </p:spTree>
     <p:extLst>
       <p:ext uri="{BB962C8B-B14F-4D97-AF65-F5344CB8AC3E}">
-        <p14:creationId xmlns:p14="http://schemas.microsoft.com/office/powerpoint/2010/main" val="1576403606"/>
+        <p14:creationId xmlns:p14="http://schemas.microsoft.com/office/powerpoint/2010/main" val="2027752513"/>
       </p:ext>
     </p:extLst>
   </p:cSld>
@@ -4234,7 +4234,7 @@
           <p:cNvPr id="7" name="grill-me">
             <a:extLst xmlns:a="http://schemas.openxmlformats.org/drawingml/2006/main">
               <a:ext uri="{FF2B5EF4-FFF2-40B4-BE49-F238E27FC236}">
-                <a16:creationId xmlns:a16="http://schemas.microsoft.com/office/drawing/2014/main" id="{0D04181B-6E5F-44A5-A4A4-E48B8B7C940C}"/>
+                <a16:creationId xmlns:a16="http://schemas.microsoft.com/office/drawing/2014/main" id="{ACA5A1EA-82A4-4D40-9D23-7892B49A6262}"/>
               </a:ext>
             </a:extLst>
           </p:cNvPr>
@@ -4291,7 +4291,7 @@
           <p:cNvPr id="2" name="04">
             <a:extLst xmlns:a="http://schemas.openxmlformats.org/drawingml/2006/main">
               <a:ext uri="{FF2B5EF4-FFF2-40B4-BE49-F238E27FC236}">
-                <a16:creationId xmlns:a16="http://schemas.microsoft.com/office/drawing/2014/main" id="{848B3BD4-1D00-41D2-A18E-592E5D788986}"/>
+                <a16:creationId xmlns:a16="http://schemas.microsoft.com/office/drawing/2014/main" id="{F1C646FA-7739-4422-BAE7-550B4839DA98}"/>
               </a:ext>
             </a:extLst>
           </p:cNvPr>
@@ -4348,7 +4348,7 @@
           <p:cNvPr id="3" name="質問に答えながら、曖昧な点や&#10;抜けている条件を確認する。">
             <a:extLst xmlns:a="http://schemas.openxmlformats.org/drawingml/2006/main">
               <a:ext uri="{FF2B5EF4-FFF2-40B4-BE49-F238E27FC236}">
-                <a16:creationId xmlns:a16="http://schemas.microsoft.com/office/drawing/2014/main" id="{402E8A30-B74C-4B86-9F2B-22379F8A0329}"/>
+                <a16:creationId xmlns:a16="http://schemas.microsoft.com/office/drawing/2014/main" id="{F1BB2873-43CA-4088-9646-5966E49FA296}"/>
               </a:ext>
             </a:extLst>
           </p:cNvPr>
@@ -4436,7 +4436,7 @@
           <p:cNvPr id="4" name="文書にも残したいときは grill-with-docs">
             <a:extLst xmlns:a="http://schemas.openxmlformats.org/drawingml/2006/main">
               <a:ext uri="{FF2B5EF4-FFF2-40B4-BE49-F238E27FC236}">
-                <a16:creationId xmlns:a16="http://schemas.microsoft.com/office/drawing/2014/main" id="{378D8C5A-96B8-4AA5-9AF0-826C0D57FD5D}"/>
+                <a16:creationId xmlns:a16="http://schemas.microsoft.com/office/drawing/2014/main" id="{FCEC04ED-962F-41BD-8AF9-6FEE4BF8475E}"/>
               </a:ext>
             </a:extLst>
           </p:cNvPr>
@@ -4493,7 +4493,7 @@
           <p:cNvPr id="5" name="質問に加えて、用語や設計判断も文書に残す。">
             <a:extLst xmlns:a="http://schemas.openxmlformats.org/drawingml/2006/main">
               <a:ext uri="{FF2B5EF4-FFF2-40B4-BE49-F238E27FC236}">
-                <a16:creationId xmlns:a16="http://schemas.microsoft.com/office/drawing/2014/main" id="{73F29269-C252-4BB7-8519-F50FB3EF96EE}"/>
+                <a16:creationId xmlns:a16="http://schemas.microsoft.com/office/drawing/2014/main" id="{9F11333B-82A9-4DAD-A2EE-73A08A735B11}"/>
               </a:ext>
             </a:extLst>
           </p:cNvPr>
@@ -4550,7 +4550,7 @@
           <p:cNvPr id="6" name="出典：Matt Pocock / mattpocock/skills（MITライ">
             <a:extLst xmlns:a="http://schemas.openxmlformats.org/drawingml/2006/main">
               <a:ext uri="{FF2B5EF4-FFF2-40B4-BE49-F238E27FC236}">
-                <a16:creationId xmlns:a16="http://schemas.microsoft.com/office/drawing/2014/main" id="{23032C39-4FD3-4D4A-B2FB-D583B3D52129}"/>
+                <a16:creationId xmlns:a16="http://schemas.microsoft.com/office/drawing/2014/main" id="{B1025DC8-CC20-4027-BC32-13338A20B844}"/>
               </a:ext>
             </a:extLst>
           </p:cNvPr>
@@ -4596,7 +4596,7 @@
                 <a:latin typeface="Noto Sans JP"/>
                 <a:ea typeface="Noto Sans JP"/>
                 <a:cs typeface="Noto Sans JP"/>
-                <a:hlinkClick xmlns:r="http://schemas.openxmlformats.org/officeDocument/2006/relationships" r:id="Ra176839842384867"/>
+                <a:hlinkClick xmlns:r="http://schemas.openxmlformats.org/officeDocument/2006/relationships" r:id="Redc2f1e803cc4241"/>
               </a:rPr>
               <a:t>出典：Matt Pocock / mattpocock/skills（MITライセンス）</a:t>
             </a:r>
@@ -4606,7 +4606,7 @@
     </p:spTree>
     <p:extLst>
       <p:ext uri="{BB962C8B-B14F-4D97-AF65-F5344CB8AC3E}">
-        <p14:creationId xmlns:p14="http://schemas.microsoft.com/office/powerpoint/2010/main" val="617947132"/>
+        <p14:creationId xmlns:p14="http://schemas.microsoft.com/office/powerpoint/2010/main" val="1951735795"/>
       </p:ext>
     </p:extLst>
   </p:cSld>
@@ -4637,7 +4637,7 @@
           <p:cNvPr id="10" name="grill-me の追加と呼び出し">
             <a:extLst xmlns:a="http://schemas.openxmlformats.org/drawingml/2006/main">
               <a:ext uri="{FF2B5EF4-FFF2-40B4-BE49-F238E27FC236}">
-                <a16:creationId xmlns:a16="http://schemas.microsoft.com/office/drawing/2014/main" id="{23BF4831-13DD-4AE2-B5EB-022ED06547C9}"/>
+                <a16:creationId xmlns:a16="http://schemas.microsoft.com/office/drawing/2014/main" id="{F0A44894-0833-4837-878D-58EDCC3156B6}"/>
               </a:ext>
             </a:extLst>
           </p:cNvPr>
@@ -4694,7 +4694,7 @@
           <p:cNvPr id="2" name="05">
             <a:extLst xmlns:a="http://schemas.openxmlformats.org/drawingml/2006/main">
               <a:ext uri="{FF2B5EF4-FFF2-40B4-BE49-F238E27FC236}">
-                <a16:creationId xmlns:a16="http://schemas.microsoft.com/office/drawing/2014/main" id="{1518ECA2-F3E6-4322-A076-F68A0C993605}"/>
+                <a16:creationId xmlns:a16="http://schemas.microsoft.com/office/drawing/2014/main" id="{F9C80C3E-679E-4B17-8F86-05407A24BA46}"/>
               </a:ext>
             </a:extLst>
           </p:cNvPr>
@@ -4751,7 +4751,7 @@
           <p:cNvPr id="3" name="例：Claude Code（コマンドはBash / zsh）">
             <a:extLst xmlns:a="http://schemas.openxmlformats.org/drawingml/2006/main">
               <a:ext uri="{FF2B5EF4-FFF2-40B4-BE49-F238E27FC236}">
-                <a16:creationId xmlns:a16="http://schemas.microsoft.com/office/drawing/2014/main" id="{51953E80-54C9-4E74-94F0-D66D38906139}"/>
+                <a16:creationId xmlns:a16="http://schemas.microsoft.com/office/drawing/2014/main" id="{4DFCD8D1-9AC1-4809-8E9A-6CEDE80C3E3E}"/>
               </a:ext>
             </a:extLst>
           </p:cNvPr>
@@ -4808,7 +4808,7 @@
           <p:cNvPr id="4" name="1   作業フォルダーで追加する">
             <a:extLst xmlns:a="http://schemas.openxmlformats.org/drawingml/2006/main">
               <a:ext uri="{FF2B5EF4-FFF2-40B4-BE49-F238E27FC236}">
-                <a16:creationId xmlns:a16="http://schemas.microsoft.com/office/drawing/2014/main" id="{E285D392-51AC-40C5-9D72-0BDCC485737D}"/>
+                <a16:creationId xmlns:a16="http://schemas.microsoft.com/office/drawing/2014/main" id="{64DB8F33-D416-4437-B40F-91D067AA7105}"/>
               </a:ext>
             </a:extLst>
           </p:cNvPr>
@@ -4865,7 +4865,7 @@
           <p:cNvPr id="5" name="npx skills@latest add mattpocock/skills ">
             <a:extLst xmlns:a="http://schemas.openxmlformats.org/drawingml/2006/main">
               <a:ext uri="{FF2B5EF4-FFF2-40B4-BE49-F238E27FC236}">
-                <a16:creationId xmlns:a16="http://schemas.microsoft.com/office/drawing/2014/main" id="{0370BC59-8F5F-421A-83BC-1C3BC07E9331}"/>
+                <a16:creationId xmlns:a16="http://schemas.microsoft.com/office/drawing/2014/main" id="{A91D3C64-DCDA-46DE-A501-682C7A39C47C}"/>
               </a:ext>
             </a:extLst>
           </p:cNvPr>
@@ -4953,7 +4953,7 @@
           <p:cNvPr id="6" name="2   Claude Codeのチャットで呼び出す">
             <a:extLst xmlns:a="http://schemas.openxmlformats.org/drawingml/2006/main">
               <a:ext uri="{FF2B5EF4-FFF2-40B4-BE49-F238E27FC236}">
-                <a16:creationId xmlns:a16="http://schemas.microsoft.com/office/drawing/2014/main" id="{3BCD59DF-E96E-43F9-9CC0-6AF08B403C6A}"/>
+                <a16:creationId xmlns:a16="http://schemas.microsoft.com/office/drawing/2014/main" id="{D4DBC9B8-8052-4318-9EA7-C295384A215D}"/>
               </a:ext>
             </a:extLst>
           </p:cNvPr>
@@ -5010,7 +5010,7 @@
           <p:cNvPr id="7" name="/grill-me">
             <a:extLst xmlns:a="http://schemas.openxmlformats.org/drawingml/2006/main">
               <a:ext uri="{FF2B5EF4-FFF2-40B4-BE49-F238E27FC236}">
-                <a16:creationId xmlns:a16="http://schemas.microsoft.com/office/drawing/2014/main" id="{2D591C19-0BC5-4685-ABF5-2995C6C23CA9}"/>
+                <a16:creationId xmlns:a16="http://schemas.microsoft.com/office/drawing/2014/main" id="{47A409FA-D24C-4B36-A40B-B9B20D97FFEF}"/>
               </a:ext>
             </a:extLst>
           </p:cNvPr>
@@ -5067,7 +5067,7 @@
           <p:cNvPr id="8" name="Azure Functionsで社内向けAPIを作りたいです。&#10;方式設計Agen">
             <a:extLst xmlns:a="http://schemas.openxmlformats.org/drawingml/2006/main">
               <a:ext uri="{FF2B5EF4-FFF2-40B4-BE49-F238E27FC236}">
-                <a16:creationId xmlns:a16="http://schemas.microsoft.com/office/drawing/2014/main" id="{E3DF2690-BB38-4A1C-9670-92CA2EC97B9A}"/>
+                <a16:creationId xmlns:a16="http://schemas.microsoft.com/office/drawing/2014/main" id="{4C00BF00-D2A3-439E-AA18-053EAEC0B035}"/>
               </a:ext>
             </a:extLst>
           </p:cNvPr>
@@ -5145,7 +5145,7 @@
                 <a:ea typeface="Noto Sans JP"/>
                 <a:cs typeface="Noto Sans JP"/>
               </a:rPr>
-              <a:t>方式設計Agentに渡す前に、認証と公開範囲を詰めたいです。</a:t>
+              <a:t>方式設計Agentに渡す前に、利用者と接続・認証を詰めたいです。</a:t>
             </a:r>
           </a:p>
         </p:txBody>
@@ -5155,7 +5155,7 @@
           <p:cNvPr id="9" name="Node.js / npm が必要です。grilling は grill-me ">
             <a:extLst xmlns:a="http://schemas.openxmlformats.org/drawingml/2006/main">
               <a:ext uri="{FF2B5EF4-FFF2-40B4-BE49-F238E27FC236}">
-                <a16:creationId xmlns:a16="http://schemas.microsoft.com/office/drawing/2014/main" id="{FD9B1935-03F3-4679-9E78-36A6E9E86CF7}"/>
+                <a16:creationId xmlns:a16="http://schemas.microsoft.com/office/drawing/2014/main" id="{44170E13-112A-4131-BE1A-7E175F305996}"/>
               </a:ext>
             </a:extLst>
           </p:cNvPr>
@@ -5210,7 +5210,7 @@
     </p:spTree>
     <p:extLst>
       <p:ext uri="{BB962C8B-B14F-4D97-AF65-F5344CB8AC3E}">
-        <p14:creationId xmlns:p14="http://schemas.microsoft.com/office/powerpoint/2010/main" val="1709730104"/>
+        <p14:creationId xmlns:p14="http://schemas.microsoft.com/office/powerpoint/2010/main" val="1461115574"/>
       </p:ext>
     </p:extLst>
   </p:cSld>
@@ -5241,7 +5241,7 @@
           <p:cNvPr id="12" name="grill-me の会話例">
             <a:extLst xmlns:a="http://schemas.openxmlformats.org/drawingml/2006/main">
               <a:ext uri="{FF2B5EF4-FFF2-40B4-BE49-F238E27FC236}">
-                <a16:creationId xmlns:a16="http://schemas.microsoft.com/office/drawing/2014/main" id="{295258FB-13DF-48D0-9B98-558E7D285F27}"/>
+                <a16:creationId xmlns:a16="http://schemas.microsoft.com/office/drawing/2014/main" id="{687F0C1F-C485-43B4-AB2E-0FC2F1297C19}"/>
               </a:ext>
             </a:extLst>
           </p:cNvPr>
@@ -5298,7 +5298,7 @@
           <p:cNvPr id="2" name="06">
             <a:extLst xmlns:a="http://schemas.openxmlformats.org/drawingml/2006/main">
               <a:ext uri="{FF2B5EF4-FFF2-40B4-BE49-F238E27FC236}">
-                <a16:creationId xmlns:a16="http://schemas.microsoft.com/office/drawing/2014/main" id="{FCB4CD87-21A9-46F4-96BA-7A4C6AF675AB}"/>
+                <a16:creationId xmlns:a16="http://schemas.microsoft.com/office/drawing/2014/main" id="{0E9A702A-EC65-460E-B34A-BB8D4FBB292E}"/>
               </a:ext>
             </a:extLst>
           </p:cNvPr>
@@ -5355,7 +5355,7 @@
           <p:cNvPr id="3" name="質問に推奨案も付くので、回答を考えやすい。">
             <a:extLst xmlns:a="http://schemas.openxmlformats.org/drawingml/2006/main">
               <a:ext uri="{FF2B5EF4-FFF2-40B4-BE49-F238E27FC236}">
-                <a16:creationId xmlns:a16="http://schemas.microsoft.com/office/drawing/2014/main" id="{2CAB2FA4-2222-4C72-8C11-F6CF789968EF}"/>
+                <a16:creationId xmlns:a16="http://schemas.microsoft.com/office/drawing/2014/main" id="{18DCDE12-0F3E-4919-BCA9-DF650451E778}"/>
               </a:ext>
             </a:extLst>
           </p:cNvPr>
@@ -5412,7 +5412,7 @@
           <p:cNvPr id="4" name="AI">
             <a:extLst xmlns:a="http://schemas.openxmlformats.org/drawingml/2006/main">
               <a:ext uri="{FF2B5EF4-FFF2-40B4-BE49-F238E27FC236}">
-                <a16:creationId xmlns:a16="http://schemas.microsoft.com/office/drawing/2014/main" id="{D6ECE38B-6A1F-4E5D-90A7-C5F31A41191C}"/>
+                <a16:creationId xmlns:a16="http://schemas.microsoft.com/office/drawing/2014/main" id="{4B153022-9F9C-4187-B9B5-C17A5088C4FF}"/>
               </a:ext>
             </a:extLst>
           </p:cNvPr>
@@ -5466,10 +5466,10 @@
       </p:sp>
       <p:sp>
         <p:nvSpPr>
-          <p:cNvPr id="5" name="誰がAPIを呼び出しますか？">
-            <a:extLst xmlns:a="http://schemas.openxmlformats.org/drawingml/2006/main">
-              <a:ext uri="{FF2B5EF4-FFF2-40B4-BE49-F238E27FC236}">
-                <a16:creationId xmlns:a16="http://schemas.microsoft.com/office/drawing/2014/main" id="{35551281-A06F-48A0-B916-B5FBCF5E12E2}"/>
+          <p:cNvPr id="5" name="Q1  誰がAPIを使いますか？">
+            <a:extLst xmlns:a="http://schemas.openxmlformats.org/drawingml/2006/main">
+              <a:ext uri="{FF2B5EF4-FFF2-40B4-BE49-F238E27FC236}">
+                <a16:creationId xmlns:a16="http://schemas.microsoft.com/office/drawing/2014/main" id="{3D73D93B-696B-4823-9194-6396BD89EE63}"/>
               </a:ext>
             </a:extLst>
           </p:cNvPr>
@@ -5516,17 +5516,17 @@
                 <a:ea typeface="Noto Sans JP"/>
                 <a:cs typeface="Noto Sans JP"/>
               </a:rPr>
-              <a:t>誰がAPIを呼び出しますか？</a:t>
-            </a:r>
-          </a:p>
-        </p:txBody>
-      </p:sp>
-      <p:sp>
-        <p:nvSpPr>
-          <p:cNvPr id="6" name="推奨案：まずは社内システム専用に絞る。">
-            <a:extLst xmlns:a="http://schemas.openxmlformats.org/drawingml/2006/main">
-              <a:ext uri="{FF2B5EF4-FFF2-40B4-BE49-F238E27FC236}">
-                <a16:creationId xmlns:a16="http://schemas.microsoft.com/office/drawing/2014/main" id="{780C5989-9FE3-481E-B5FB-4CD149E91E32}"/>
+              <a:t>Q1  誰がAPIを使いますか？</a:t>
+            </a:r>
+          </a:p>
+        </p:txBody>
+      </p:sp>
+      <p:sp>
+        <p:nvSpPr>
+          <p:cNvPr id="6" name="推奨案：まずは社内の担当者に絞る。">
+            <a:extLst xmlns:a="http://schemas.openxmlformats.org/drawingml/2006/main">
+              <a:ext uri="{FF2B5EF4-FFF2-40B4-BE49-F238E27FC236}">
+                <a16:creationId xmlns:a16="http://schemas.microsoft.com/office/drawing/2014/main" id="{34ABB630-7104-478B-86A0-6ED16B67DF8C}"/>
               </a:ext>
             </a:extLst>
           </p:cNvPr>
@@ -5573,17 +5573,17 @@
                 <a:ea typeface="Noto Sans JP"/>
                 <a:cs typeface="Noto Sans JP"/>
               </a:rPr>
-              <a:t>推奨案：まずは社内システム専用に絞る。</a:t>
-            </a:r>
-          </a:p>
-        </p:txBody>
-      </p:sp>
-      <p:sp>
-        <p:nvSpPr>
-          <p:cNvPr id="7" name="インターネットからのアクセスは必要ですか？">
-            <a:extLst xmlns:a="http://schemas.openxmlformats.org/drawingml/2006/main">
-              <a:ext uri="{FF2B5EF4-FFF2-40B4-BE49-F238E27FC236}">
-                <a16:creationId xmlns:a16="http://schemas.microsoft.com/office/drawing/2014/main" id="{E5E688B7-81B5-466D-9E1F-8E9C34BD4A93}"/>
+              <a:t>推奨案：まずは社内の担当者に絞る。</a:t>
+            </a:r>
+          </a:p>
+        </p:txBody>
+      </p:sp>
+      <p:sp>
+        <p:nvSpPr>
+          <p:cNvPr id="7" name="Q2  社外からも使いますか？">
+            <a:extLst xmlns:a="http://schemas.openxmlformats.org/drawingml/2006/main">
+              <a:ext uri="{FF2B5EF4-FFF2-40B4-BE49-F238E27FC236}">
+                <a16:creationId xmlns:a16="http://schemas.microsoft.com/office/drawing/2014/main" id="{1EC0B75B-4E4F-49AA-A54B-D07487CF046E}"/>
               </a:ext>
             </a:extLst>
           </p:cNvPr>
@@ -5630,7 +5630,7 @@
                 <a:ea typeface="Noto Sans JP"/>
                 <a:cs typeface="Noto Sans JP"/>
               </a:rPr>
-              <a:t>インターネットからのアクセスは必要ですか？</a:t>
+              <a:t>Q2  社外からも使いますか？</a:t>
             </a:r>
           </a:p>
         </p:txBody>
@@ -5640,7 +5640,7 @@
           <p:cNvPr id="8" name="推奨案：社内ネットワークからの利用に限定する。">
             <a:extLst xmlns:a="http://schemas.openxmlformats.org/drawingml/2006/main">
               <a:ext uri="{FF2B5EF4-FFF2-40B4-BE49-F238E27FC236}">
-                <a16:creationId xmlns:a16="http://schemas.microsoft.com/office/drawing/2014/main" id="{F3E4C201-648C-46EF-971D-3E47A1450443}"/>
+                <a16:creationId xmlns:a16="http://schemas.microsoft.com/office/drawing/2014/main" id="{61242D09-57F7-402E-88B9-AC177BF445DF}"/>
               </a:ext>
             </a:extLst>
           </p:cNvPr>
@@ -5697,7 +5697,7 @@
           <p:cNvPr id="9" name="自分">
             <a:extLst xmlns:a="http://schemas.openxmlformats.org/drawingml/2006/main">
               <a:ext uri="{FF2B5EF4-FFF2-40B4-BE49-F238E27FC236}">
-                <a16:creationId xmlns:a16="http://schemas.microsoft.com/office/drawing/2014/main" id="{B61990FA-3B95-48CB-8B03-15AA975401CF}"/>
+                <a16:creationId xmlns:a16="http://schemas.microsoft.com/office/drawing/2014/main" id="{217E83D7-C4C1-4E8B-AA6D-489E6B7864DE}"/>
               </a:ext>
             </a:extLst>
           </p:cNvPr>
@@ -5751,10 +5751,10 @@
       </p:sp>
       <p:sp>
         <p:nvSpPr>
-          <p:cNvPr id="10" name="社内バッチから呼びます。&#10;社外からのアクセスは不要です。">
-            <a:extLst xmlns:a="http://schemas.openxmlformats.org/drawingml/2006/main">
-              <a:ext uri="{FF2B5EF4-FFF2-40B4-BE49-F238E27FC236}">
-                <a16:creationId xmlns:a16="http://schemas.microsoft.com/office/drawing/2014/main" id="{42D91E06-10F4-42A6-859E-87689AED6960}"/>
+          <p:cNvPr id="10" name="Q1  社内の担当者が業務画面から使います。&#10;Q2  いいえ、社内ネットワークか">
+            <a:extLst xmlns:a="http://schemas.openxmlformats.org/drawingml/2006/main">
+              <a:ext uri="{FF2B5EF4-FFF2-40B4-BE49-F238E27FC236}">
+                <a16:creationId xmlns:a16="http://schemas.microsoft.com/office/drawing/2014/main" id="{1CDA057D-30B3-4280-A245-C635AC47DE47}"/>
               </a:ext>
             </a:extLst>
           </p:cNvPr>
@@ -5787,7 +5787,7 @@
                 <a:spcPct val="130000"/>
               </a:lnSpc>
               <a:buNone/>
-              <a:defRPr sz="2400" b="0">
+              <a:defRPr sz="2175" b="0">
                 <a:solidFill>
                   <a:srgbClr val="145AB0"/>
                 </a:solidFill>
@@ -5797,7 +5797,7 @@
               </a:defRPr>
             </a:pPr>
             <a:r>
-              <a:rPr sz="2400" b="0">
+              <a:rPr sz="2175" b="0">
                 <a:solidFill>
                   <a:srgbClr val="145AB0"/>
                 </a:solidFill>
@@ -5805,7 +5805,7 @@
                 <a:ea typeface="Noto Sans JP"/>
                 <a:cs typeface="Noto Sans JP"/>
               </a:rPr>
-              <a:t>社内バッチから呼びます。</a:t>
+              <a:t>Q1  社内の担当者が業務画面から使います。</a:t>
             </a:r>
           </a:p>
           <a:p xmlns:a="http://schemas.openxmlformats.org/drawingml/2006/main">
@@ -5814,7 +5814,7 @@
                 <a:spcPct val="130000"/>
               </a:lnSpc>
               <a:buNone/>
-              <a:defRPr sz="2400" b="0">
+              <a:defRPr sz="2175" b="0">
                 <a:solidFill>
                   <a:srgbClr val="145AB0"/>
                 </a:solidFill>
@@ -5824,7 +5824,7 @@
               </a:defRPr>
             </a:pPr>
             <a:r>
-              <a:rPr sz="2400" b="0">
+              <a:rPr sz="2175" b="0">
                 <a:solidFill>
                   <a:srgbClr val="145AB0"/>
                 </a:solidFill>
@@ -5832,7 +5832,7 @@
                 <a:ea typeface="Noto Sans JP"/>
                 <a:cs typeface="Noto Sans JP"/>
               </a:rPr>
-              <a:t>社外からのアクセスは不要です。</a:t>
+              <a:t>Q2  いいえ、社内ネットワークからだけです。</a:t>
             </a:r>
           </a:p>
         </p:txBody>
@@ -5842,7 +5842,7 @@
           <p:cNvPr id="11" name="説明用の会話例。実際の質問・推奨案・順序は変わります。">
             <a:extLst xmlns:a="http://schemas.openxmlformats.org/drawingml/2006/main">
               <a:ext uri="{FF2B5EF4-FFF2-40B4-BE49-F238E27FC236}">
-                <a16:creationId xmlns:a16="http://schemas.microsoft.com/office/drawing/2014/main" id="{C847B6E3-8B4B-4D76-BCB2-67C0DC8A9CDB}"/>
+                <a16:creationId xmlns:a16="http://schemas.microsoft.com/office/drawing/2014/main" id="{713B52C8-D75A-488D-88D9-311590763818}"/>
               </a:ext>
             </a:extLst>
           </p:cNvPr>
@@ -5897,7 +5897,7 @@
     </p:spTree>
     <p:extLst>
       <p:ext uri="{BB962C8B-B14F-4D97-AF65-F5344CB8AC3E}">
-        <p14:creationId xmlns:p14="http://schemas.microsoft.com/office/powerpoint/2010/main" val="1712460109"/>
+        <p14:creationId xmlns:p14="http://schemas.microsoft.com/office/powerpoint/2010/main" val="68924750"/>
       </p:ext>
     </p:extLst>
   </p:cSld>
@@ -5928,7 +5928,7 @@
           <p:cNvPr id="12" name="回答に合わせて、質問が続く">
             <a:extLst xmlns:a="http://schemas.openxmlformats.org/drawingml/2006/main">
               <a:ext uri="{FF2B5EF4-FFF2-40B4-BE49-F238E27FC236}">
-                <a16:creationId xmlns:a16="http://schemas.microsoft.com/office/drawing/2014/main" id="{864D9ADE-F54B-48BF-8A15-2435A33A4C3C}"/>
+                <a16:creationId xmlns:a16="http://schemas.microsoft.com/office/drawing/2014/main" id="{A5829D60-7055-4110-8CD7-958A7A06C68C}"/>
               </a:ext>
             </a:extLst>
           </p:cNvPr>
@@ -5985,7 +5985,7 @@
           <p:cNvPr id="2" name="07">
             <a:extLst xmlns:a="http://schemas.openxmlformats.org/drawingml/2006/main">
               <a:ext uri="{FF2B5EF4-FFF2-40B4-BE49-F238E27FC236}">
-                <a16:creationId xmlns:a16="http://schemas.microsoft.com/office/drawing/2014/main" id="{929872CC-237B-45FB-A5D1-ADF501F7FE94}"/>
+                <a16:creationId xmlns:a16="http://schemas.microsoft.com/office/drawing/2014/main" id="{0B9D119A-34BF-413B-A0E2-F26BF00B53DE}"/>
               </a:ext>
             </a:extLst>
           </p:cNvPr>
@@ -6039,10 +6039,10 @@
       </p:sp>
       <p:sp>
         <p:nvSpPr>
-          <p:cNvPr id="3" name="「社内バッチから呼ぶ」と分かったので、次を確認。">
-            <a:extLst xmlns:a="http://schemas.openxmlformats.org/drawingml/2006/main">
-              <a:ext uri="{FF2B5EF4-FFF2-40B4-BE49-F238E27FC236}">
-                <a16:creationId xmlns:a16="http://schemas.microsoft.com/office/drawing/2014/main" id="{C76739DC-0F28-4559-91C5-5ABD2F5C311D}"/>
+          <p:cNvPr id="3" name="「社内ネットワークからだけ」と分かったので、次を確認。">
+            <a:extLst xmlns:a="http://schemas.openxmlformats.org/drawingml/2006/main">
+              <a:ext uri="{FF2B5EF4-FFF2-40B4-BE49-F238E27FC236}">
+                <a16:creationId xmlns:a16="http://schemas.microsoft.com/office/drawing/2014/main" id="{B7EDA7FE-8FE0-4C7C-87DE-1B53AC25E7F8}"/>
               </a:ext>
             </a:extLst>
           </p:cNvPr>
@@ -6089,7 +6089,7 @@
                 <a:ea typeface="Noto Sans JP"/>
                 <a:cs typeface="Noto Sans JP"/>
               </a:rPr>
-              <a:t>「社内バッチから呼ぶ」と分かったので、次を確認。</a:t>
+              <a:t>「社内ネットワークからだけ」と分かったので、次を確認。</a:t>
             </a:r>
           </a:p>
         </p:txBody>
@@ -6099,7 +6099,7 @@
           <p:cNvPr id="4" name="AI">
             <a:extLst xmlns:a="http://schemas.openxmlformats.org/drawingml/2006/main">
               <a:ext uri="{FF2B5EF4-FFF2-40B4-BE49-F238E27FC236}">
-                <a16:creationId xmlns:a16="http://schemas.microsoft.com/office/drawing/2014/main" id="{7125768F-BBD2-42DB-9D84-E79E46B8BD99}"/>
+                <a16:creationId xmlns:a16="http://schemas.microsoft.com/office/drawing/2014/main" id="{D1F17584-956D-475E-AFA8-721D108FC053}"/>
               </a:ext>
             </a:extLst>
           </p:cNvPr>
@@ -6153,10 +6153,10 @@
       </p:sp>
       <p:sp>
         <p:nvSpPr>
-          <p:cNvPr id="5" name="バッチはどこで動いていますか？">
-            <a:extLst xmlns:a="http://schemas.openxmlformats.org/drawingml/2006/main">
-              <a:ext uri="{FF2B5EF4-FFF2-40B4-BE49-F238E27FC236}">
-                <a16:creationId xmlns:a16="http://schemas.microsoft.com/office/drawing/2014/main" id="{660D900D-C27E-41E3-80F8-6011255716EB}"/>
+          <p:cNvPr id="5" name="Q3  社内からAzureへどう接続しますか？">
+            <a:extLst xmlns:a="http://schemas.openxmlformats.org/drawingml/2006/main">
+              <a:ext uri="{FF2B5EF4-FFF2-40B4-BE49-F238E27FC236}">
+                <a16:creationId xmlns:a16="http://schemas.microsoft.com/office/drawing/2014/main" id="{68BD7835-A92B-4862-9B08-5DB1DAFAB1D4}"/>
               </a:ext>
             </a:extLst>
           </p:cNvPr>
@@ -6203,17 +6203,17 @@
                 <a:ea typeface="Noto Sans JP"/>
                 <a:cs typeface="Noto Sans JP"/>
               </a:rPr>
-              <a:t>バッチはどこで動いていますか？</a:t>
-            </a:r>
-          </a:p>
-        </p:txBody>
-      </p:sp>
-      <p:sp>
-        <p:nvSpPr>
-          <p:cNvPr id="6" name="推奨案：既存の実行環境をそのまま使う。">
-            <a:extLst xmlns:a="http://schemas.openxmlformats.org/drawingml/2006/main">
-              <a:ext uri="{FF2B5EF4-FFF2-40B4-BE49-F238E27FC236}">
-                <a16:creationId xmlns:a16="http://schemas.microsoft.com/office/drawing/2014/main" id="{BC4D104D-3569-4190-91C0-0D60985FADFC}"/>
+              <a:t>Q3  社内からAzureへどう接続しますか？</a:t>
+            </a:r>
+          </a:p>
+        </p:txBody>
+      </p:sp>
+      <p:sp>
+        <p:nvSpPr>
+          <p:cNvPr id="6" name="推奨案：既存の閉域接続を使う。">
+            <a:extLst xmlns:a="http://schemas.openxmlformats.org/drawingml/2006/main">
+              <a:ext uri="{FF2B5EF4-FFF2-40B4-BE49-F238E27FC236}">
+                <a16:creationId xmlns:a16="http://schemas.microsoft.com/office/drawing/2014/main" id="{EF78656B-ECE5-446D-BA3B-D33320A1A849}"/>
               </a:ext>
             </a:extLst>
           </p:cNvPr>
@@ -6260,17 +6260,17 @@
                 <a:ea typeface="Noto Sans JP"/>
                 <a:cs typeface="Noto Sans JP"/>
               </a:rPr>
-              <a:t>推奨案：既存の実行環境をそのまま使う。</a:t>
-            </a:r>
-          </a:p>
-        </p:txBody>
-      </p:sp>
-      <p:sp>
-        <p:nvSpPr>
-          <p:cNvPr id="7" name="APIの認証方式に指定はありますか？">
-            <a:extLst xmlns:a="http://schemas.openxmlformats.org/drawingml/2006/main">
-              <a:ext uri="{FF2B5EF4-FFF2-40B4-BE49-F238E27FC236}">
-                <a16:creationId xmlns:a16="http://schemas.microsoft.com/office/drawing/2014/main" id="{93EBB3F1-838D-49FA-808B-63D6594D88DE}"/>
+              <a:t>推奨案：既存の閉域接続を使う。</a:t>
+            </a:r>
+          </a:p>
+        </p:txBody>
+      </p:sp>
+      <p:sp>
+        <p:nvSpPr>
+          <p:cNvPr id="7" name="Q4  利用者の認証はどうしますか？">
+            <a:extLst xmlns:a="http://schemas.openxmlformats.org/drawingml/2006/main">
+              <a:ext uri="{FF2B5EF4-FFF2-40B4-BE49-F238E27FC236}">
+                <a16:creationId xmlns:a16="http://schemas.microsoft.com/office/drawing/2014/main" id="{48824CB7-A949-4E44-B49F-E62867F1D906}"/>
               </a:ext>
             </a:extLst>
           </p:cNvPr>
@@ -6317,17 +6317,17 @@
                 <a:ea typeface="Noto Sans JP"/>
                 <a:cs typeface="Noto Sans JP"/>
               </a:rPr>
-              <a:t>APIの認証方式に指定はありますか？</a:t>
-            </a:r>
-          </a:p>
-        </p:txBody>
-      </p:sp>
-      <p:sp>
-        <p:nvSpPr>
-          <p:cNvPr id="8" name="推奨案：既存のID基盤に合わせる。">
-            <a:extLst xmlns:a="http://schemas.openxmlformats.org/drawingml/2006/main">
-              <a:ext uri="{FF2B5EF4-FFF2-40B4-BE49-F238E27FC236}">
-                <a16:creationId xmlns:a16="http://schemas.microsoft.com/office/drawing/2014/main" id="{237A9539-8C22-4C16-B268-7FFC5F276C8E}"/>
+              <a:t>Q4  利用者の認証はどうしますか？</a:t>
+            </a:r>
+          </a:p>
+        </p:txBody>
+      </p:sp>
+      <p:sp>
+        <p:nvSpPr>
+          <p:cNvPr id="8" name="推奨案：既存のEntra IDを使う。">
+            <a:extLst xmlns:a="http://schemas.openxmlformats.org/drawingml/2006/main">
+              <a:ext uri="{FF2B5EF4-FFF2-40B4-BE49-F238E27FC236}">
+                <a16:creationId xmlns:a16="http://schemas.microsoft.com/office/drawing/2014/main" id="{8CF7252D-A5CD-43EA-A142-4BAB16E1B1BC}"/>
               </a:ext>
             </a:extLst>
           </p:cNvPr>
@@ -6374,7 +6374,7 @@
                 <a:ea typeface="Noto Sans JP"/>
                 <a:cs typeface="Noto Sans JP"/>
               </a:rPr>
-              <a:t>推奨案：既存のID基盤に合わせる。</a:t>
+              <a:t>推奨案：既存のEntra IDを使う。</a:t>
             </a:r>
           </a:p>
         </p:txBody>
@@ -6384,7 +6384,7 @@
           <p:cNvPr id="9" name="自分">
             <a:extLst xmlns:a="http://schemas.openxmlformats.org/drawingml/2006/main">
               <a:ext uri="{FF2B5EF4-FFF2-40B4-BE49-F238E27FC236}">
-                <a16:creationId xmlns:a16="http://schemas.microsoft.com/office/drawing/2014/main" id="{515E1082-571E-4D81-9D75-FE12FCAAA9E6}"/>
+                <a16:creationId xmlns:a16="http://schemas.microsoft.com/office/drawing/2014/main" id="{6BF78FCC-C11C-4F46-A9B6-28DE955398ED}"/>
               </a:ext>
             </a:extLst>
           </p:cNvPr>
@@ -6438,10 +6438,10 @@
       </p:sp>
       <p:sp>
         <p:nvSpPr>
-          <p:cNvPr id="10" name="バッチはオンプレです。Azureへの閉域接続はあります。&#10;認証はEntra ID">
-            <a:extLst xmlns:a="http://schemas.openxmlformats.org/drawingml/2006/main">
-              <a:ext uri="{FF2B5EF4-FFF2-40B4-BE49-F238E27FC236}">
-                <a16:creationId xmlns:a16="http://schemas.microsoft.com/office/drawing/2014/main" id="{BBD31ED3-C2CD-46FA-BBFC-2B3B016D98EC}"/>
+          <p:cNvPr id="10" name="Q3  既存の閉域接続を使います。&#10;Q4  社内のEntra IDアカウントで認">
+            <a:extLst xmlns:a="http://schemas.openxmlformats.org/drawingml/2006/main">
+              <a:ext uri="{FF2B5EF4-FFF2-40B4-BE49-F238E27FC236}">
+                <a16:creationId xmlns:a16="http://schemas.microsoft.com/office/drawing/2014/main" id="{C74B0D2C-B05E-47AE-A714-290ED4C1F884}"/>
               </a:ext>
             </a:extLst>
           </p:cNvPr>
@@ -6492,7 +6492,7 @@
                 <a:ea typeface="Noto Sans JP"/>
                 <a:cs typeface="Noto Sans JP"/>
               </a:rPr>
-              <a:t>バッチはオンプレです。Azureへの閉域接続はあります。</a:t>
+              <a:t>Q3  既存の閉域接続を使います。</a:t>
             </a:r>
           </a:p>
           <a:p xmlns:a="http://schemas.openxmlformats.org/drawingml/2006/main">
@@ -6519,7 +6519,7 @@
                 <a:ea typeface="Noto Sans JP"/>
                 <a:cs typeface="Noto Sans JP"/>
               </a:rPr>
-              <a:t>認証はEntra IDのアプリ認証に統一します。</a:t>
+              <a:t>Q4  社内のEntra IDアカウントで認証します。</a:t>
             </a:r>
           </a:p>
         </p:txBody>
@@ -6529,7 +6529,7 @@
           <p:cNvPr id="11" name="説明用の会話例（前ページの続き）。">
             <a:extLst xmlns:a="http://schemas.openxmlformats.org/drawingml/2006/main">
               <a:ext uri="{FF2B5EF4-FFF2-40B4-BE49-F238E27FC236}">
-                <a16:creationId xmlns:a16="http://schemas.microsoft.com/office/drawing/2014/main" id="{7360D425-E524-46B2-B2AB-A639A2959C2C}"/>
+                <a16:creationId xmlns:a16="http://schemas.microsoft.com/office/drawing/2014/main" id="{093E055D-C8B0-48C5-9FA7-57B058BB92CA}"/>
               </a:ext>
             </a:extLst>
           </p:cNvPr>
@@ -6584,7 +6584,7 @@
     </p:spTree>
     <p:extLst>
       <p:ext uri="{BB962C8B-B14F-4D97-AF65-F5344CB8AC3E}">
-        <p14:creationId xmlns:p14="http://schemas.microsoft.com/office/powerpoint/2010/main" val="1396904096"/>
+        <p14:creationId xmlns:p14="http://schemas.microsoft.com/office/powerpoint/2010/main" val="225927612"/>
       </p:ext>
     </p:extLst>
   </p:cSld>
@@ -6615,7 +6615,7 @@
           <p:cNvPr id="8" name="質問で詰めた要件を、方式設計Agentへ">
             <a:extLst xmlns:a="http://schemas.openxmlformats.org/drawingml/2006/main">
               <a:ext uri="{FF2B5EF4-FFF2-40B4-BE49-F238E27FC236}">
-                <a16:creationId xmlns:a16="http://schemas.microsoft.com/office/drawing/2014/main" id="{28E8A912-0F7B-4746-B0E5-377124525120}"/>
+                <a16:creationId xmlns:a16="http://schemas.microsoft.com/office/drawing/2014/main" id="{8168C922-A857-46BF-9367-AAA748338285}"/>
               </a:ext>
             </a:extLst>
           </p:cNvPr>
@@ -6672,7 +6672,7 @@
           <p:cNvPr id="2" name="08">
             <a:extLst xmlns:a="http://schemas.openxmlformats.org/drawingml/2006/main">
               <a:ext uri="{FF2B5EF4-FFF2-40B4-BE49-F238E27FC236}">
-                <a16:creationId xmlns:a16="http://schemas.microsoft.com/office/drawing/2014/main" id="{317B79EC-3125-48A4-B9E1-46EDA9524AAB}"/>
+                <a16:creationId xmlns:a16="http://schemas.microsoft.com/office/drawing/2014/main" id="{58331CFB-AE7D-46F5-89FD-65EF6D44FA3A}"/>
               </a:ext>
             </a:extLst>
           </p:cNvPr>
@@ -6813,7 +6813,7 @@
                           <a:ea typeface="Noto Sans JP"/>
                           <a:cs typeface="Noto Sans JP"/>
                         </a:rPr>
-                        <a:t>呼び出し元</a:t>
+                        <a:t>利用者</a:t>
                       </a:r>
                     </a:p>
                   </a:txBody>
@@ -6839,7 +6839,7 @@
                           <a:ea typeface="Noto Sans JP"/>
                           <a:cs typeface="Noto Sans JP"/>
                         </a:rPr>
-                        <a:t>社内バッチ（オンプレ）</a:t>
+                        <a:t>社内の担当者（業務画面）</a:t>
                       </a:r>
                     </a:p>
                   </a:txBody>
@@ -6893,7 +6893,7 @@
                           <a:ea typeface="Noto Sans JP"/>
                           <a:cs typeface="Noto Sans JP"/>
                         </a:rPr>
-                        <a:t>社内のみ</a:t>
+                        <a:t>社内ネットワークのみ</a:t>
                       </a:r>
                     </a:p>
                   </a:txBody>
@@ -7001,7 +7001,7 @@
                           <a:ea typeface="Noto Sans JP"/>
                           <a:cs typeface="Noto Sans JP"/>
                         </a:rPr>
-                        <a:t>Entra IDのアプリ認証</a:t>
+                        <a:t>Entra IDの社内アカウント</a:t>
                       </a:r>
                     </a:p>
                   </a:txBody>
@@ -7021,7 +7021,7 @@
           <p:cNvPr id="4" name="回答をまとめて渡す">
             <a:extLst xmlns:a="http://schemas.openxmlformats.org/drawingml/2006/main">
               <a:ext uri="{FF2B5EF4-FFF2-40B4-BE49-F238E27FC236}">
-                <a16:creationId xmlns:a16="http://schemas.microsoft.com/office/drawing/2014/main" id="{0D07DE6A-A6F3-4944-B2AA-4CB45B97B15D}"/>
+                <a16:creationId xmlns:a16="http://schemas.microsoft.com/office/drawing/2014/main" id="{8267719B-F9C5-4DD0-9F1F-93C5720D2F51}"/>
               </a:ext>
             </a:extLst>
           </p:cNvPr>
@@ -7075,10 +7075,10 @@
       </p:sp>
       <p:sp>
         <p:nvSpPr>
-          <p:cNvPr id="5" name="呼び出し元や接続・認証の&#10;条件を添えて、方式案の&#10;作成を依頼する。">
-            <a:extLst xmlns:a="http://schemas.openxmlformats.org/drawingml/2006/main">
-              <a:ext uri="{FF2B5EF4-FFF2-40B4-BE49-F238E27FC236}">
-                <a16:creationId xmlns:a16="http://schemas.microsoft.com/office/drawing/2014/main" id="{DD0E7E71-5805-47DD-88A8-88C9F183BF5B}"/>
+          <p:cNvPr id="5" name="利用者や接続・認証の&#10;条件を添えて、方式案の&#10;作成を依頼する。">
+            <a:extLst xmlns:a="http://schemas.openxmlformats.org/drawingml/2006/main">
+              <a:ext uri="{FF2B5EF4-FFF2-40B4-BE49-F238E27FC236}">
+                <a16:creationId xmlns:a16="http://schemas.microsoft.com/office/drawing/2014/main" id="{34437978-0629-4CE7-8DB2-095F95B1CCE6}"/>
               </a:ext>
             </a:extLst>
           </p:cNvPr>
@@ -7129,7 +7129,7 @@
                 <a:ea typeface="Noto Sans JP"/>
                 <a:cs typeface="Noto Sans JP"/>
               </a:rPr>
-              <a:t>呼び出し元や接続・認証の</a:t>
+              <a:t>利用者や接続・認証の</a:t>
             </a:r>
           </a:p>
           <a:p xmlns:a="http://schemas.openxmlformats.org/drawingml/2006/main">
@@ -7193,7 +7193,7 @@
           <p:cNvPr id="6" name="分からない条件は、&#10;未確認と明記する。">
             <a:extLst xmlns:a="http://schemas.openxmlformats.org/drawingml/2006/main">
               <a:ext uri="{FF2B5EF4-FFF2-40B4-BE49-F238E27FC236}">
-                <a16:creationId xmlns:a16="http://schemas.microsoft.com/office/drawing/2014/main" id="{F70CBE9D-288A-46D1-877A-4425FB02934E}"/>
+                <a16:creationId xmlns:a16="http://schemas.microsoft.com/office/drawing/2014/main" id="{6ADC7F89-FCFE-408C-AC43-B87EE290C2D9}"/>
               </a:ext>
             </a:extLst>
           </p:cNvPr>
@@ -7281,7 +7281,7 @@
           <p:cNvPr id="7" name="この例では未確認：APIの処理内容、呼び出し量、可用性など。">
             <a:extLst xmlns:a="http://schemas.openxmlformats.org/drawingml/2006/main">
               <a:ext uri="{FF2B5EF4-FFF2-40B4-BE49-F238E27FC236}">
-                <a16:creationId xmlns:a16="http://schemas.microsoft.com/office/drawing/2014/main" id="{70C1A279-1A27-45C0-9CD7-672ABA846FEE}"/>
+                <a16:creationId xmlns:a16="http://schemas.microsoft.com/office/drawing/2014/main" id="{9C445E92-ACF7-4877-9925-A5C898A67FC1}"/>
               </a:ext>
             </a:extLst>
           </p:cNvPr>
@@ -7336,7 +7336,7 @@
     </p:spTree>
     <p:extLst>
       <p:ext uri="{BB962C8B-B14F-4D97-AF65-F5344CB8AC3E}">
-        <p14:creationId xmlns:p14="http://schemas.microsoft.com/office/powerpoint/2010/main" val="1734239139"/>
+        <p14:creationId xmlns:p14="http://schemas.microsoft.com/office/powerpoint/2010/main" val="1655720918"/>
       </p:ext>
     </p:extLst>
   </p:cSld>
@@ -7367,7 +7367,7 @@
           <p:cNvPr id="4" name="09">
             <a:extLst xmlns:a="http://schemas.openxmlformats.org/drawingml/2006/main">
               <a:ext uri="{FF2B5EF4-FFF2-40B4-BE49-F238E27FC236}">
-                <a16:creationId xmlns:a16="http://schemas.microsoft.com/office/drawing/2014/main" id="{81B5755F-D442-4BF6-B828-951BE7C0FD9B}"/>
+                <a16:creationId xmlns:a16="http://schemas.microsoft.com/office/drawing/2014/main" id="{B86847E8-5B21-4E8B-A4D2-A490D2E0861E}"/>
               </a:ext>
             </a:extLst>
           </p:cNvPr>
@@ -7424,7 +7424,7 @@
           <p:cNvPr id="2" name="デモをやってみます">
             <a:extLst xmlns:a="http://schemas.openxmlformats.org/drawingml/2006/main">
               <a:ext uri="{FF2B5EF4-FFF2-40B4-BE49-F238E27FC236}">
-                <a16:creationId xmlns:a16="http://schemas.microsoft.com/office/drawing/2014/main" id="{EB829F5C-A72B-4C1D-9407-72008C624457}"/>
+                <a16:creationId xmlns:a16="http://schemas.microsoft.com/office/drawing/2014/main" id="{14A7BEE3-558F-44CC-AC97-19160F160234}"/>
               </a:ext>
             </a:extLst>
           </p:cNvPr>
@@ -7481,7 +7481,7 @@
           <p:cNvPr id="3" name="今日の晩ご飯を grill-me で考える">
             <a:extLst xmlns:a="http://schemas.openxmlformats.org/drawingml/2006/main">
               <a:ext uri="{FF2B5EF4-FFF2-40B4-BE49-F238E27FC236}">
-                <a16:creationId xmlns:a16="http://schemas.microsoft.com/office/drawing/2014/main" id="{BF4ECB08-8117-4687-9385-C8B8B1AC97FF}"/>
+                <a16:creationId xmlns:a16="http://schemas.microsoft.com/office/drawing/2014/main" id="{30E270F1-D61D-4403-A68C-F17436CEBF04}"/>
               </a:ext>
             </a:extLst>
           </p:cNvPr>
@@ -7536,7 +7536,7 @@
     </p:spTree>
     <p:extLst>
       <p:ext uri="{BB962C8B-B14F-4D97-AF65-F5344CB8AC3E}">
-        <p14:creationId xmlns:p14="http://schemas.microsoft.com/office/powerpoint/2010/main" val="604762143"/>
+        <p14:creationId xmlns:p14="http://schemas.microsoft.com/office/powerpoint/2010/main" val="1047874722"/>
       </p:ext>
     </p:extLst>
   </p:cSld>

</xml_diff>